<commit_message>
Sederhanakan bahasa dan kurangi kepadatan slide rangkuman kelayakan model
Co-Authored-By: Claude Opus 5.5 <noreply@anthropic.com>
Claude-Session: https://claude.ai/code/session_01RwTK1q8JkWDwXbpfgwmLot
</commit_message>
<xml_diff>
--- a/Slide - Rangkuman Kelayakan Model (ringkas).pptx
+++ b/Slide - Rangkuman Kelayakan Model (ringkas).pptx
@@ -621,7 +621,7 @@
           <a:lstStyle/>
           <a:p>
             <a:r>
-              <a:t>Sebagai rangkuman, ada tiga bukti kelayakan model. Pertama, uji struktur lolos seluruhnya: satuan konsisten, stok cocok, enam loop bekerja, dan 17 uji ekstrem tidak ada yang gagal. Kedua, uji perilaku cukup baik: saat diuji terpisah semua MAPE di bawah 20 persen, saat dijalankan bersama tidak ada MAPE buruk, dan selisihnya berasal dari satu sumber, yaitu pertumbuhan wisatawan. Ketiga, kalibrasi tidak mengganti satu pun nilai parameter. Ada empat batas pemakaian: model bukan alat ramal angka pasti, belum diuji dengan data baru, tidak memuat kejadian mendadak, dan laju pertumbuhan serta penurunan wisatawan tidak bisa dipisahkan oleh data. Jadi model layak dipakai untuk membandingkan arah dan besar perbedaan antarskenario kebijakan 2025 sampai 2050.</a:t>
+              <a:t>Jadi, apakah model ini layak dipakai? Ada tiga hal yang saya periksa. Dari uji struktur, persamaan dan satuannya konsisten, dan model tetap masuk akal walaupun diberi nilai ekstrem. Dari uji perilaku, hasil simulasi cukup dekat dengan data. Selisih terbesar ada pada jumlah wisatawan. Dari kalibrasi, tidak ada nilai parameter yang perlu diganti; selisih wisatawan itu muncul karena lonjakan wisatawan setelah pandemi, yang memang tidak dimodelkan. Ada beberapa hal yang perlu diingat: hasilnya dibaca sebagai arah dan perbandingan, bukan angka pasti; model belum diuji dengan data baru; pandemi dan bencana tidak dimodelkan; dan laju pertumbuhan serta penurunan wisatawan belum bisa dipisahkan oleh data. Dengan catatan itu, model dapat dipakai untuk membandingkan skenario kebijakan sampai 2050.</a:t>
             </a:r>
           </a:p>
         </p:txBody>
@@ -4012,7 +4012,7 @@
                 <a:cs typeface="Calibri (MS) Bold"/>
                 <a:sym typeface="Calibri (MS) Bold"/>
               </a:rPr>
-              <a:t>Model layak dipakai untuk simulasi skenario, dengan batas pemakaian yang jelas</a:t>
+              <a:t>Model sudah cukup layak untuk membandingkan skenario kebijakan</a:t>
             </a:r>
           </a:p>
         </p:txBody>
@@ -6011,8 +6011,8 @@
         </p:nvSpPr>
         <p:spPr>
           <a:xfrm>
-            <a:off x="822960" y="1783080"/>
-            <a:ext cx="5394960" cy="2971800"/>
+            <a:off x="822960" y="1920240"/>
+            <a:ext cx="5394960" cy="2331720"/>
           </a:xfrm>
           <a:prstGeom prst="roundRect">
             <a:avLst>
@@ -6059,8 +6059,8 @@
         </p:nvSpPr>
         <p:spPr>
           <a:xfrm>
-            <a:off x="822960" y="1783080"/>
-            <a:ext cx="5394960" cy="914400"/>
+            <a:off x="822960" y="1920240"/>
+            <a:ext cx="5394960" cy="960120"/>
           </a:xfrm>
           <a:prstGeom prst="roundRect">
             <a:avLst>
@@ -6090,7 +6090,7 @@
           </a:fontRef>
         </p:style>
         <p:txBody>
-          <a:bodyPr rtlCol="0" anchor="ctr" wrap="square" lIns="182880" rIns="182880" tIns="109728" bIns="109728"/>
+          <a:bodyPr rtlCol="0" anchor="ctr" wrap="square" lIns="228600" rIns="228600" tIns="109728" bIns="109728"/>
           <a:lstStyle/>
           <a:p>
             <a:pPr algn="l">
@@ -6099,13 +6099,13 @@
               </a:spcAft>
             </a:pPr>
             <a:r>
-              <a:rPr sz="1380" b="1" i="0">
+              <a:rPr sz="1440" b="1" i="0">
                 <a:solidFill>
                   <a:srgbClr val="D7EEF2"/>
                 </a:solidFill>
                 <a:latin typeface="Calibri (MS) Bold"/>
               </a:rPr>
-              <a:t>1  Uji struktur</a:t>
+              <a:t>Uji struktur</a:t>
             </a:r>
           </a:p>
           <a:p>
@@ -6115,13 +6115,13 @@
               </a:spcAft>
             </a:pPr>
             <a:r>
-              <a:rPr sz="1950" b="1" i="0">
+              <a:rPr sz="2300" b="1" i="0">
                 <a:solidFill>
                   <a:srgbClr val="FFFFFF"/>
                 </a:solidFill>
                 <a:latin typeface="Calibri (MS) Bold"/>
               </a:rPr>
-              <a:t>LOLOS</a:t>
+              <a:t>Lolos</a:t>
             </a:r>
           </a:p>
         </p:txBody>
@@ -6134,8 +6134,8 @@
         </p:nvSpPr>
         <p:spPr>
           <a:xfrm>
-            <a:off x="1051560" y="2852928"/>
-            <a:ext cx="4983480" cy="1828800"/>
+            <a:off x="1097280" y="3108960"/>
+            <a:ext cx="4937760" cy="1371600"/>
           </a:xfrm>
           <a:prstGeom prst="rect">
             <a:avLst/>
@@ -6154,7 +6154,7 @@
               </a:spcAft>
             </a:pPr>
             <a:r>
-              <a:rPr sz="1550" b="1" i="0">
+              <a:rPr sz="1610" b="1" i="0">
                 <a:solidFill>
                   <a:srgbClr val="1E7A43"/>
                 </a:solidFill>
@@ -6163,13 +6163,13 @@
               <a:t>✓  </a:t>
             </a:r>
             <a:r>
-              <a:rPr sz="1550" b="0" i="0">
+              <a:rPr sz="1610" b="0" i="0">
                 <a:solidFill>
                   <a:srgbClr val="14313B"/>
                 </a:solidFill>
                 <a:latin typeface="Calibri (MS)"/>
               </a:rPr>
-              <a:t>Satuan seluruh persamaan konsisten</a:t>
+              <a:t>Persamaan dan satuannya konsisten</a:t>
             </a:r>
           </a:p>
           <a:p>
@@ -6179,7 +6179,7 @@
               </a:spcAft>
             </a:pPr>
             <a:r>
-              <a:rPr sz="1550" b="1" i="0">
+              <a:rPr sz="1610" b="1" i="0">
                 <a:solidFill>
                   <a:srgbClr val="1E7A43"/>
                 </a:solidFill>
@@ -6188,63 +6188,13 @@
               <a:t>✓  </a:t>
             </a:r>
             <a:r>
-              <a:rPr sz="1550" b="0" i="0">
+              <a:rPr sz="1610" b="0" i="0">
                 <a:solidFill>
                   <a:srgbClr val="14313B"/>
                 </a:solidFill>
                 <a:latin typeface="Calibri (MS)"/>
               </a:rPr>
-              <a:t>Jumlah tiap stok cocok, tidak ada selisih</a:t>
-            </a:r>
-          </a:p>
-          <a:p>
-            <a:pPr algn="l">
-              <a:spcAft>
-                <a:spcPts val="400"/>
-              </a:spcAft>
-            </a:pPr>
-            <a:r>
-              <a:rPr sz="1550" b="1" i="0">
-                <a:solidFill>
-                  <a:srgbClr val="1E7A43"/>
-                </a:solidFill>
-                <a:latin typeface="Calibri (MS) Bold"/>
-              </a:rPr>
-              <a:t>✓  </a:t>
-            </a:r>
-            <a:r>
-              <a:rPr sz="1550" b="0" i="0">
-                <a:solidFill>
-                  <a:srgbClr val="14313B"/>
-                </a:solidFill>
-                <a:latin typeface="Calibri (MS)"/>
-              </a:rPr>
-              <a:t>6 loop bekerja sesuai rancangan</a:t>
-            </a:r>
-          </a:p>
-          <a:p>
-            <a:pPr algn="l">
-              <a:spcAft>
-                <a:spcPts val="400"/>
-              </a:spcAft>
-            </a:pPr>
-            <a:r>
-              <a:rPr sz="1550" b="1" i="0">
-                <a:solidFill>
-                  <a:srgbClr val="1E7A43"/>
-                </a:solidFill>
-                <a:latin typeface="Calibri (MS) Bold"/>
-              </a:rPr>
-              <a:t>✓  </a:t>
-            </a:r>
-            <a:r>
-              <a:rPr sz="1550" b="0" i="0">
-                <a:solidFill>
-                  <a:srgbClr val="14313B"/>
-                </a:solidFill>
-                <a:latin typeface="Calibri (MS)"/>
-              </a:rPr>
-              <a:t>17 uji kondisi ekstrem: 0 gagal</a:t>
+              <a:t>Tetap masuk akal saat diberi nilai ekstrem</a:t>
             </a:r>
           </a:p>
         </p:txBody>
@@ -6257,7 +6207,7 @@
         </p:nvSpPr>
         <p:spPr>
           <a:xfrm>
-            <a:off x="6236208" y="3246120"/>
+            <a:off x="6236208" y="3108960"/>
             <a:ext cx="192024" cy="274320"/>
           </a:xfrm>
           <a:prstGeom prst="rightArrow">
@@ -6301,8 +6251,8 @@
         </p:nvSpPr>
         <p:spPr>
           <a:xfrm>
-            <a:off x="6446520" y="1783080"/>
-            <a:ext cx="5394960" cy="2971800"/>
+            <a:off x="6446520" y="1920240"/>
+            <a:ext cx="5394960" cy="2331720"/>
           </a:xfrm>
           <a:prstGeom prst="roundRect">
             <a:avLst>
@@ -6349,8 +6299,8 @@
         </p:nvSpPr>
         <p:spPr>
           <a:xfrm>
-            <a:off x="6446520" y="1783080"/>
-            <a:ext cx="5394960" cy="914400"/>
+            <a:off x="6446520" y="1920240"/>
+            <a:ext cx="5394960" cy="960120"/>
           </a:xfrm>
           <a:prstGeom prst="roundRect">
             <a:avLst>
@@ -6380,7 +6330,7 @@
           </a:fontRef>
         </p:style>
         <p:txBody>
-          <a:bodyPr rtlCol="0" anchor="ctr" wrap="square" lIns="182880" rIns="182880" tIns="109728" bIns="109728"/>
+          <a:bodyPr rtlCol="0" anchor="ctr" wrap="square" lIns="228600" rIns="228600" tIns="109728" bIns="109728"/>
           <a:lstStyle/>
           <a:p>
             <a:pPr algn="l">
@@ -6389,13 +6339,13 @@
               </a:spcAft>
             </a:pPr>
             <a:r>
-              <a:rPr sz="1380" b="1" i="0">
+              <a:rPr sz="1440" b="1" i="0">
                 <a:solidFill>
                   <a:srgbClr val="D7EEF2"/>
                 </a:solidFill>
                 <a:latin typeface="Calibri (MS) Bold"/>
               </a:rPr>
-              <a:t>2  Uji perilaku</a:t>
+              <a:t>Uji perilaku</a:t>
             </a:r>
           </a:p>
           <a:p>
@@ -6405,13 +6355,13 @@
               </a:spcAft>
             </a:pPr>
             <a:r>
-              <a:rPr sz="1950" b="1" i="0">
+              <a:rPr sz="2300" b="1" i="0">
                 <a:solidFill>
                   <a:srgbClr val="FFFFFF"/>
                 </a:solidFill>
                 <a:latin typeface="Calibri (MS) Bold"/>
               </a:rPr>
-              <a:t>CUKUP BAIK</a:t>
+              <a:t>Cukup baik</a:t>
             </a:r>
           </a:p>
         </p:txBody>
@@ -6424,8 +6374,8 @@
         </p:nvSpPr>
         <p:spPr>
           <a:xfrm>
-            <a:off x="6675120" y="2852928"/>
-            <a:ext cx="4983480" cy="1828800"/>
+            <a:off x="6720840" y="3108960"/>
+            <a:ext cx="4937760" cy="1371600"/>
           </a:xfrm>
           <a:prstGeom prst="rect">
             <a:avLst/>
@@ -6444,7 +6394,7 @@
               </a:spcAft>
             </a:pPr>
             <a:r>
-              <a:rPr sz="1550" b="1" i="0">
+              <a:rPr sz="1610" b="1" i="0">
                 <a:solidFill>
                   <a:srgbClr val="1E7A43"/>
                 </a:solidFill>
@@ -6453,13 +6403,13 @@
               <a:t>✓  </a:t>
             </a:r>
             <a:r>
-              <a:rPr sz="1550" b="0" i="0">
+              <a:rPr sz="1610" b="0" i="0">
                 <a:solidFill>
                   <a:srgbClr val="14313B"/>
                 </a:solidFill>
                 <a:latin typeface="Calibri (MS)"/>
               </a:rPr>
-              <a:t>Diuji terpisah: semua MAPE &lt; 20%</a:t>
+              <a:t>Simulasi cukup dekat dengan data</a:t>
             </a:r>
           </a:p>
           <a:p>
@@ -6469,7 +6419,7 @@
               </a:spcAft>
             </a:pPr>
             <a:r>
-              <a:rPr sz="1550" b="1" i="0">
+              <a:rPr sz="1610" b="1" i="0">
                 <a:solidFill>
                   <a:srgbClr val="1E7A43"/>
                 </a:solidFill>
@@ -6478,38 +6428,13 @@
               <a:t>✓  </a:t>
             </a:r>
             <a:r>
-              <a:rPr sz="1550" b="0" i="0">
+              <a:rPr sz="1610" b="0" i="0">
                 <a:solidFill>
                   <a:srgbClr val="14313B"/>
                 </a:solidFill>
                 <a:latin typeface="Calibri (MS)"/>
               </a:rPr>
-              <a:t>Dijalankan bersama: tidak ada MAPE buruk</a:t>
-            </a:r>
-          </a:p>
-          <a:p>
-            <a:pPr algn="l">
-              <a:spcAft>
-                <a:spcPts val="400"/>
-              </a:spcAft>
-            </a:pPr>
-            <a:r>
-              <a:rPr sz="1550" b="1" i="0">
-                <a:solidFill>
-                  <a:srgbClr val="1E7A43"/>
-                </a:solidFill>
-                <a:latin typeface="Calibri (MS) Bold"/>
-              </a:rPr>
-              <a:t>✓  </a:t>
-            </a:r>
-            <a:r>
-              <a:rPr sz="1550" b="0" i="0">
-                <a:solidFill>
-                  <a:srgbClr val="14313B"/>
-                </a:solidFill>
-                <a:latin typeface="Calibri (MS)"/>
-              </a:rPr>
-              <a:t>Selisih berasal dari satu sumber: pertumbuhan wisatawan</a:t>
+              <a:t>Selisih terbesar ada pada jumlah wisatawan</a:t>
             </a:r>
           </a:p>
         </p:txBody>
@@ -6522,7 +6447,7 @@
         </p:nvSpPr>
         <p:spPr>
           <a:xfrm>
-            <a:off x="11859768" y="3246120"/>
+            <a:off x="11859768" y="3108960"/>
             <a:ext cx="192024" cy="274320"/>
           </a:xfrm>
           <a:prstGeom prst="rightArrow">
@@ -6566,8 +6491,8 @@
         </p:nvSpPr>
         <p:spPr>
           <a:xfrm>
-            <a:off x="12070080" y="1783080"/>
-            <a:ext cx="5394960" cy="2971800"/>
+            <a:off x="12070080" y="1920240"/>
+            <a:ext cx="5394960" cy="2331720"/>
           </a:xfrm>
           <a:prstGeom prst="roundRect">
             <a:avLst>
@@ -6614,8 +6539,8 @@
         </p:nvSpPr>
         <p:spPr>
           <a:xfrm>
-            <a:off x="12070080" y="1783080"/>
-            <a:ext cx="5394960" cy="914400"/>
+            <a:off x="12070080" y="1920240"/>
+            <a:ext cx="5394960" cy="960120"/>
           </a:xfrm>
           <a:prstGeom prst="roundRect">
             <a:avLst>
@@ -6645,7 +6570,7 @@
           </a:fontRef>
         </p:style>
         <p:txBody>
-          <a:bodyPr rtlCol="0" anchor="ctr" wrap="square" lIns="182880" rIns="182880" tIns="109728" bIns="109728"/>
+          <a:bodyPr rtlCol="0" anchor="ctr" wrap="square" lIns="228600" rIns="228600" tIns="109728" bIns="109728"/>
           <a:lstStyle/>
           <a:p>
             <a:pPr algn="l">
@@ -6654,13 +6579,13 @@
               </a:spcAft>
             </a:pPr>
             <a:r>
-              <a:rPr sz="1380" b="1" i="0">
+              <a:rPr sz="1440" b="1" i="0">
                 <a:solidFill>
                   <a:srgbClr val="D7EEF2"/>
                 </a:solidFill>
                 <a:latin typeface="Calibri (MS) Bold"/>
               </a:rPr>
-              <a:t>3  Kalibrasi</a:t>
+              <a:t>Kalibrasi</a:t>
             </a:r>
           </a:p>
           <a:p>
@@ -6670,13 +6595,13 @@
               </a:spcAft>
             </a:pPr>
             <a:r>
-              <a:rPr sz="1950" b="1" i="0">
+              <a:rPr sz="2300" b="1" i="0">
                 <a:solidFill>
                   <a:srgbClr val="FFFFFF"/>
                 </a:solidFill>
                 <a:latin typeface="Calibri (MS) Bold"/>
               </a:rPr>
-              <a:t>NILAI DARI DATA DIPAKAI</a:t>
+              <a:t>Nilai tetap</a:t>
             </a:r>
           </a:p>
         </p:txBody>
@@ -6689,8 +6614,8 @@
         </p:nvSpPr>
         <p:spPr>
           <a:xfrm>
-            <a:off x="12298680" y="2852928"/>
-            <a:ext cx="4983480" cy="1828800"/>
+            <a:off x="12344400" y="3108960"/>
+            <a:ext cx="4937760" cy="1371600"/>
           </a:xfrm>
           <a:prstGeom prst="rect">
             <a:avLst/>
@@ -6709,7 +6634,7 @@
               </a:spcAft>
             </a:pPr>
             <a:r>
-              <a:rPr sz="1550" b="1" i="0">
+              <a:rPr sz="1610" b="1" i="0">
                 <a:solidFill>
                   <a:srgbClr val="1E7A43"/>
                 </a:solidFill>
@@ -6718,13 +6643,13 @@
               <a:t>✓  </a:t>
             </a:r>
             <a:r>
-              <a:rPr sz="1550" b="0" i="0">
+              <a:rPr sz="1610" b="0" i="0">
                 <a:solidFill>
                   <a:srgbClr val="14313B"/>
                 </a:solidFill>
                 <a:latin typeface="Calibri (MS)"/>
               </a:rPr>
-              <a:t>3 parameter dikalibrasi, 0 diganti</a:t>
+              <a:t>Tidak ada parameter yang perlu diganti</a:t>
             </a:r>
           </a:p>
           <a:p>
@@ -6734,7 +6659,7 @@
               </a:spcAft>
             </a:pPr>
             <a:r>
-              <a:rPr sz="1550" b="1" i="0">
+              <a:rPr sz="1610" b="1" i="0">
                 <a:solidFill>
                   <a:srgbClr val="1E7A43"/>
                 </a:solidFill>
@@ -6743,81 +6668,52 @@
               <a:t>✓  </a:t>
             </a:r>
             <a:r>
-              <a:rPr sz="1550" b="0" i="0">
+              <a:rPr sz="1610" b="0" i="0">
                 <a:solidFill>
                   <a:srgbClr val="14313B"/>
                 </a:solidFill>
                 <a:latin typeface="Calibri (MS)"/>
               </a:rPr>
-              <a:t>Selisih wisatawan karena lonjakan setelah pandemi, di luar cakupan model</a:t>
-            </a:r>
-          </a:p>
-        </p:txBody>
-      </p:sp>
-      <p:sp>
-        <p:nvSpPr>
-          <p:cNvPr id="81" name="Rounded Rectangle 80"/>
-          <p:cNvSpPr/>
+              <a:t>Selisih wisatawan karena lonjakan setelah pandemi</a:t>
+            </a:r>
+          </a:p>
+        </p:txBody>
+      </p:sp>
+      <p:sp>
+        <p:nvSpPr>
+          <p:cNvPr id="81" name="TextBox 80"/>
+          <p:cNvSpPr txBox="1"/>
           <p:nvPr/>
         </p:nvSpPr>
         <p:spPr>
           <a:xfrm>
-            <a:off x="822960" y="4983480"/>
+            <a:off x="822960" y="4709160"/>
             <a:ext cx="16642080" cy="457200"/>
           </a:xfrm>
-          <a:prstGeom prst="roundRect">
-            <a:avLst>
-              <a:gd name="adj" fmla="val 8000"/>
-            </a:avLst>
+          <a:prstGeom prst="rect">
+            <a:avLst/>
           </a:prstGeom>
-          <a:solidFill>
-            <a:srgbClr val="0B5E6E"/>
-          </a:solidFill>
-          <a:ln>
-            <a:noFill/>
-          </a:ln>
-          <a:effectLst/>
+          <a:noFill/>
         </p:spPr>
-        <p:style>
-          <a:lnRef idx="1">
-            <a:schemeClr val="accent1"/>
-          </a:lnRef>
-          <a:fillRef idx="3">
-            <a:schemeClr val="accent1"/>
-          </a:fillRef>
-          <a:effectRef idx="2">
-            <a:schemeClr val="accent1"/>
-          </a:effectRef>
-          <a:fontRef idx="minor">
-            <a:schemeClr val="lt1"/>
-          </a:fontRef>
-        </p:style>
-        <p:txBody>
-          <a:bodyPr rtlCol="0" anchor="ctr" wrap="square" lIns="137160" rIns="137160" tIns="109728" bIns="109728"/>
+        <p:txBody>
+          <a:bodyPr wrap="square" anchor="t" lIns="0" rIns="0" tIns="0" bIns="0">
+            <a:spAutoFit/>
+          </a:bodyPr>
           <a:lstStyle/>
           <a:p>
             <a:pPr algn="l">
               <a:spcAft>
-                <a:spcPts val="300"/>
+                <a:spcPts val="400"/>
               </a:spcAft>
             </a:pPr>
             <a:r>
-              <a:rPr sz="1550" b="1" i="0">
+              <a:rPr sz="1610" b="1" i="0">
                 <a:solidFill>
-                  <a:srgbClr val="FFFFFF"/>
+                  <a:srgbClr val="0B5E6E"/>
                 </a:solidFill>
                 <a:latin typeface="Calibri (MS) Bold"/>
               </a:rPr>
-              <a:t>Batas pemakaian</a:t>
-            </a:r>
-            <a:r>
-              <a:rPr sz="1260" b="0" i="0">
-                <a:solidFill>
-                  <a:srgbClr val="D7EEF2"/>
-                </a:solidFill>
-                <a:latin typeface="Calibri (MS)"/>
-              </a:rPr>
-              <a:t>   hal yang perlu diingat saat membaca hasil model</a:t>
+              <a:t>Yang perlu diingat saat membaca hasil</a:t>
             </a:r>
           </a:p>
         </p:txBody>
@@ -6830,8 +6726,8 @@
         </p:nvSpPr>
         <p:spPr>
           <a:xfrm>
-            <a:off x="822960" y="5532120"/>
-            <a:ext cx="8229600" cy="932688"/>
+            <a:off x="822960" y="5257800"/>
+            <a:ext cx="8229600" cy="658368"/>
           </a:xfrm>
           <a:prstGeom prst="roundRect">
             <a:avLst>
@@ -6863,7 +6759,7 @@
           </a:fontRef>
         </p:style>
         <p:txBody>
-          <a:bodyPr rtlCol="0" anchor="ctr" wrap="square" lIns="164592" rIns="164592" tIns="109728" bIns="109728"/>
+          <a:bodyPr rtlCol="0" anchor="ctr" wrap="square" lIns="228600" rIns="228600" tIns="109728" bIns="109728"/>
           <a:lstStyle/>
           <a:p>
             <a:pPr algn="l">
@@ -6872,29 +6768,22 @@
               </a:spcAft>
             </a:pPr>
             <a:r>
-              <a:rPr sz="1440" b="1" i="0">
+              <a:rPr sz="1490" b="1" i="0">
                 <a:solidFill>
                   <a:srgbClr val="9B2C1F"/>
                 </a:solidFill>
                 <a:latin typeface="Calibri (MS) Bold"/>
               </a:rPr>
-              <a:t>Bukan alat ramal angka pasti</a:t>
-            </a:r>
-          </a:p>
-          <a:p>
-            <a:pPr algn="l">
-              <a:spcAft>
-                <a:spcPts val="300"/>
-              </a:spcAft>
-            </a:pPr>
-            <a:r>
-              <a:rPr sz="1320" b="0" i="0">
+              <a:t>!  </a:t>
+            </a:r>
+            <a:r>
+              <a:rPr sz="1490" b="0" i="0">
                 <a:solidFill>
                   <a:srgbClr val="14313B"/>
                 </a:solidFill>
                 <a:latin typeface="Calibri (MS)"/>
               </a:rPr>
-              <a:t>Hasil dibaca sebagai arah dan perbandingan antarskenario, bukan angka tepat untuk tahun tertentu.</a:t>
+              <a:t>Dibaca sebagai arah dan perbandingan, bukan angka pasti</a:t>
             </a:r>
           </a:p>
         </p:txBody>
@@ -6907,8 +6796,8 @@
         </p:nvSpPr>
         <p:spPr>
           <a:xfrm>
-            <a:off x="9235440" y="5532120"/>
-            <a:ext cx="8229600" cy="932688"/>
+            <a:off x="9235440" y="5257800"/>
+            <a:ext cx="8229600" cy="658368"/>
           </a:xfrm>
           <a:prstGeom prst="roundRect">
             <a:avLst>
@@ -6940,7 +6829,7 @@
           </a:fontRef>
         </p:style>
         <p:txBody>
-          <a:bodyPr rtlCol="0" anchor="ctr" wrap="square" lIns="164592" rIns="164592" tIns="109728" bIns="109728"/>
+          <a:bodyPr rtlCol="0" anchor="ctr" wrap="square" lIns="228600" rIns="228600" tIns="109728" bIns="109728"/>
           <a:lstStyle/>
           <a:p>
             <a:pPr algn="l">
@@ -6949,29 +6838,22 @@
               </a:spcAft>
             </a:pPr>
             <a:r>
-              <a:rPr sz="1440" b="1" i="0">
+              <a:rPr sz="1490" b="1" i="0">
                 <a:solidFill>
                   <a:srgbClr val="9B2C1F"/>
                 </a:solidFill>
                 <a:latin typeface="Calibri (MS) Bold"/>
               </a:rPr>
-              <a:t>Belum diuji dengan data baru</a:t>
-            </a:r>
-          </a:p>
-          <a:p>
-            <a:pPr algn="l">
-              <a:spcAft>
-                <a:spcPts val="300"/>
-              </a:spcAft>
-            </a:pPr>
-            <a:r>
-              <a:rPr sz="1320" b="0" i="0">
+              <a:t>!  </a:t>
+            </a:r>
+            <a:r>
+              <a:rPr sz="1490" b="0" i="0">
                 <a:solidFill>
                   <a:srgbClr val="14313B"/>
                 </a:solidFill>
                 <a:latin typeface="Calibri (MS)"/>
               </a:rPr>
-              <a:t>Kecocokan setelah kalibrasi dihitung dengan data yang sama, jadi bukan validasi dengan data terpisah.</a:t>
+              <a:t>Belum diuji dengan data baru</a:t>
             </a:r>
           </a:p>
         </p:txBody>
@@ -6984,8 +6866,8 @@
         </p:nvSpPr>
         <p:spPr>
           <a:xfrm>
-            <a:off x="822960" y="6583679"/>
-            <a:ext cx="8229600" cy="932688"/>
+            <a:off x="822960" y="6126480"/>
+            <a:ext cx="8229600" cy="658368"/>
           </a:xfrm>
           <a:prstGeom prst="roundRect">
             <a:avLst>
@@ -7017,7 +6899,7 @@
           </a:fontRef>
         </p:style>
         <p:txBody>
-          <a:bodyPr rtlCol="0" anchor="ctr" wrap="square" lIns="164592" rIns="164592" tIns="109728" bIns="109728"/>
+          <a:bodyPr rtlCol="0" anchor="ctr" wrap="square" lIns="228600" rIns="228600" tIns="109728" bIns="109728"/>
           <a:lstStyle/>
           <a:p>
             <a:pPr algn="l">
@@ -7026,29 +6908,22 @@
               </a:spcAft>
             </a:pPr>
             <a:r>
-              <a:rPr sz="1440" b="1" i="0">
+              <a:rPr sz="1490" b="1" i="0">
                 <a:solidFill>
                   <a:srgbClr val="9B2C1F"/>
                 </a:solidFill>
                 <a:latin typeface="Calibri (MS) Bold"/>
               </a:rPr>
-              <a:t>Tanpa kejadian mendadak</a:t>
-            </a:r>
-          </a:p>
-          <a:p>
-            <a:pPr algn="l">
-              <a:spcAft>
-                <a:spcPts val="300"/>
-              </a:spcAft>
-            </a:pPr>
-            <a:r>
-              <a:rPr sz="1320" b="0" i="0">
+              <a:t>!  </a:t>
+            </a:r>
+            <a:r>
+              <a:rPr sz="1490" b="0" i="0">
                 <a:solidFill>
                   <a:srgbClr val="14313B"/>
                 </a:solidFill>
                 <a:latin typeface="Calibri (MS)"/>
               </a:rPr>
-              <a:t>Pandemi, bencana, dan guncangan sejenis tidak dimodelkan.</a:t>
+              <a:t>Tidak memuat pandemi atau bencana</a:t>
             </a:r>
           </a:p>
         </p:txBody>
@@ -7061,8 +6936,8 @@
         </p:nvSpPr>
         <p:spPr>
           <a:xfrm>
-            <a:off x="9235440" y="6583679"/>
-            <a:ext cx="8229600" cy="932688"/>
+            <a:off x="9235440" y="6126480"/>
+            <a:ext cx="8229600" cy="658368"/>
           </a:xfrm>
           <a:prstGeom prst="roundRect">
             <a:avLst>
@@ -7094,7 +6969,7 @@
           </a:fontRef>
         </p:style>
         <p:txBody>
-          <a:bodyPr rtlCol="0" anchor="ctr" wrap="square" lIns="164592" rIns="164592" tIns="109728" bIns="109728"/>
+          <a:bodyPr rtlCol="0" anchor="ctr" wrap="square" lIns="228600" rIns="228600" tIns="109728" bIns="109728"/>
           <a:lstStyle/>
           <a:p>
             <a:pPr algn="l">
@@ -7103,29 +6978,22 @@
               </a:spcAft>
             </a:pPr>
             <a:r>
-              <a:rPr sz="1440" b="1" i="0">
+              <a:rPr sz="1490" b="1" i="0">
                 <a:solidFill>
                   <a:srgbClr val="9B2C1F"/>
                 </a:solidFill>
                 <a:latin typeface="Calibri (MS) Bold"/>
               </a:rPr>
-              <a:t>LPE dan LPD tidak bisa dipisahkan</a:t>
-            </a:r>
-          </a:p>
-          <a:p>
-            <a:pPr algn="l">
-              <a:spcAft>
-                <a:spcPts val="300"/>
-              </a:spcAft>
-            </a:pPr>
-            <a:r>
-              <a:rPr sz="1320" b="0" i="0">
+              <a:t>!  </a:t>
+            </a:r>
+            <a:r>
+              <a:rPr sz="1490" b="0" i="0">
                 <a:solidFill>
                   <a:srgbClr val="14313B"/>
                 </a:solidFill>
                 <a:latin typeface="Calibri (MS)"/>
               </a:rPr>
-              <a:t>Data hanya bisa menentukan selisih laju pertumbuhan dan penurunan wisatawan.</a:t>
+              <a:t>Laju pertumbuhan dan penurunan wisatawan belum bisa dipisahkan</a:t>
             </a:r>
           </a:p>
         </p:txBody>
@@ -7138,8 +7006,8 @@
         </p:nvSpPr>
         <p:spPr>
           <a:xfrm>
-            <a:off x="822960" y="7818120"/>
-            <a:ext cx="16642080" cy="1143000"/>
+            <a:off x="822960" y="7269480"/>
+            <a:ext cx="16642080" cy="1280160"/>
           </a:xfrm>
           <a:prstGeom prst="roundRect">
             <a:avLst>
@@ -7169,7 +7037,7 @@
           </a:fontRef>
         </p:style>
         <p:txBody>
-          <a:bodyPr rtlCol="0" anchor="ctr" wrap="square" lIns="274320" rIns="274320" tIns="109728" bIns="109728"/>
+          <a:bodyPr rtlCol="0" anchor="ctr" wrap="square" lIns="320040" rIns="320040" tIns="109728" bIns="109728"/>
           <a:lstStyle/>
           <a:p>
             <a:pPr algn="l">
@@ -7178,22 +7046,29 @@
               </a:spcAft>
             </a:pPr>
             <a:r>
-              <a:rPr sz="1610" b="1" i="0">
+              <a:rPr sz="1440" b="1" i="0">
                 <a:solidFill>
                   <a:srgbClr val="FFD23B"/>
                 </a:solidFill>
                 <a:latin typeface="Calibri (MS) Bold"/>
               </a:rPr>
-              <a:t>Keputusan  </a:t>
-            </a:r>
-            <a:r>
-              <a:rPr sz="1610" b="1" i="0">
+              <a:t>Kesimpulan</a:t>
+            </a:r>
+          </a:p>
+          <a:p>
+            <a:pPr algn="l">
+              <a:spcAft>
+                <a:spcPts val="300"/>
+              </a:spcAft>
+            </a:pPr>
+            <a:r>
+              <a:rPr sz="1670" b="1" i="0">
                 <a:solidFill>
                   <a:srgbClr val="FFFFFF"/>
                 </a:solidFill>
                 <a:latin typeface="Calibri (MS) Bold"/>
               </a:rPr>
-              <a:t>Model layak dipakai untuk membandingkan arah dan besar perbedaan antarskenario kebijakan 2025–2050.</a:t>
+              <a:t>Model dapat dipakai untuk membandingkan skenario kebijakan 2025–2050: mana yang arahnya lebih baik, dan seberapa besar bedanya.</a:t>
             </a:r>
           </a:p>
         </p:txBody>

</xml_diff>